<commit_message>
ADG: 15장 보강 — Logical Standby 모니터링(V$LOGSTDBY_TRANSACTION)
실습 주제 목록의 마지막 미이행 항목(15장 6번)을 실측해 반영한다.

- 본문에 15.6 "Logical Standby 는 다른 뷰로 본다" 신설
  (기존 15.6~15.9 를 15.7~15.10 으로 이동)
- 실습 07 트랜스크립트 추가 — 전환·모니터링·복구 전 과정
- 객관식 [중-20]·[상-10], 서술형 [추가-17] 을 이 주제로 교체
- PPT 40 → 44장

주요 실측
- Logical 로 바뀌면 V$MANAGED_STANDBY 에 MRP0 이 없고
  V$DATAGUARD_STATS 는 no rows selected — 두 지연이 통째로 사라진다
- V$LOGSTDBY_TRANSACTION 의 열은 전부 PRIMARY_ 접두어이며
  XIDUSN·SAVEPOINT_SCN·COMMIT_SCN 은 19c 에 없다 (ORA-00904)
- 이 뷰는 SQL Apply 가 도는 동안에만 채워진다.
  멈춘 뒤의 XID 는 DBA_LOGSTDBY_EVENTS 에서 찾는다 (열 이름은 XIDUSN)
- 적용 중단 재현은 ORA-26787, SKIP_TRANSACTION 은 PDB 에서 ORA-65040,
  정지 상태에서 ORA-16104 로 거부 — 원인 제거로 복구
- REMOVE CONFIGURATION 이 log_archive_config·fal_server 를 덮어
  전송이 끊긴다 (ORA-16057)

본문 29,997자, verify 21/21. 환경은 ch16-done 스냅샷으로 원복.

Co-Authored-By: Claude Opus 5 (1M context) <noreply@anthropic.com>
</commit_message>
<xml_diff>
--- a/ADG/15장/15장_V뷰기반모니터링과문제해결.pptx
+++ b/ADG/15장/15장_V뷰기반모니터링과문제해결.pptx
@@ -45,6 +45,10 @@
     <p:sldId id="293" r:id="rId45"/>
     <p:sldId id="294" r:id="rId46"/>
     <p:sldId id="295" r:id="rId47"/>
+    <p:sldId id="296" r:id="rId48"/>
+    <p:sldId id="297" r:id="rId49"/>
+    <p:sldId id="298" r:id="rId50"/>
+    <p:sldId id="299" r:id="rId51"/>
   </p:sldIdLst>
   <p:sldSz cx="12191695" cy="6858000" type="screen4x3"/>
   <p:notesSz cx="6858000" cy="9144000"/>
@@ -1801,7 +1805,7 @@
           <a:lstStyle/>
           <a:p>
             <a:r>
-              <a:t>첫 번째가 가장 중요하다. V$DATAGUARD_STATS 는 Primary 에서 no rows 이고, V$STANDBY_LOG 는 Primary 에서 전부 UNASSIGNED 다. 둘 다 오류가 나지 않으므로 같은 스크립트를 양쪽에 돌리면 Primary 에서 조용히 오판한다. V$DATABASE 로 역할을 먼저 판정하고 분기하는 구조여야 하며, 빈 결과와 오류도 구별해 처리해야 한다.</a:t>
+              <a:t>15.2.2 절에서 뷰가 조회된다고 값이 있는 것은 아니라고 했는데 여기서는 한 걸음 더 나간다. 역할이 Logical 이 되면 뷰가 통째로 빈다. 감시 스크립트를 역할과 무관하게 돌리면 지연을 못 읽은 것을 장애로 오인한다. 판정은 STATE 한 값으로 한다. IDLE 이 정상, APPLYING 이 적용 중, SQL APPLY NOT ON 이면 멈춘 것이다. 진행은 DBA_LOGSTDBY_PROGRESS 의 세 SCN 으로 본다. 실측은 APPLIED 2988122 / READ 2988125 / NEWEST 2988129 로 거의 같았고 이것이 따라잡았다는 뜻이다.</a:t>
             </a:r>
           </a:p>
         </p:txBody>
@@ -1871,7 +1875,7 @@
           <a:lstStyle/>
           <a:p>
             <a:r>
-              <a:t>boston 의 DG_ERR 가 0 인 것이 의미가 있다. 실습 03 의 오류는 Primary 쪽에만 기록됐다. 보내는 쪽이 실패를 알고 받는 쪽은 모르기 때문이며, 양쪽을 다 봐야 하는 이유가 여기 있다. DG_ERR 에는 시간 조건이 들어 있으므로 한 시간이 지나면 자동으로 0 이 된다. 이 값 하나가 지금 봐야 할 일이 있는가에 답한다. 나머지 항목의 기댓값도 미리 정해 두어야 스크립트가 판정할 수 있다.</a:t>
+              <a:t>200 만 행을 한 트랜잭션으로 넣고 2초 간격으로 조회하면 행이 잡힌다. PRIMARY_ 가 붙는 이유는 이 XID 가 Standby 의 것이 아니라 Primary 에서 그 트랜잭션이 받았던 번호이기 때문이다. 그래야 Primary 의 V$TRANSACTION 과 대조할 수 있다. PRIMARY_START_TIME 과 지금 시각의 차이가 그 트랜잭션이 붙잡고 있는 시간이며 실측 52초였다. 적용이 느릴 때 원인을 트랜잭션 단위로 설명할 수 있는 유일한 뷰다.</a:t>
             </a:r>
           </a:p>
         </p:txBody>
@@ -1941,7 +1945,7 @@
           <a:lstStyle/>
           <a:p>
             <a:r>
-              <a:t>SRL_ACTIVE 가 이 점검표의 핵심이다. 지연이 0 으로 보이는 두 상황 모두에서 ACTIVE 인 SRL 이 사라지므로 이 값 하나가 두 사례를 모두 잡는다. 지연을 버리라는 뜻은 아니다. 흐르고는 있는데 느린 상황은 지연만이 잡는다. 두 종류를 함께 두어야 끊겼다와 느리다를 구별할 수 있고, 그래야 대응의 시급성도 달라진다. 대응의 시급성이 달라지므로 이 구분이 실무에서 중요하다.</a:t>
+              <a:t>Standby 에서 SYS 로 복제 대상 행을 지운 뒤 Primary 에서 그 행을 고치면 적용이 멈춘다. STATE 는 SQL APPLY NOT ON 이 되고 DBA_LOGSTDBY_EVENTS 에 ORA-26787 이 표 이름과 키 값까지 함께 남는다. ORA-16222 는 자동 재시도다. 건너뛰기가 거부되면 원인을 없애는 편이 낫다. 지운 행을 되돌려 놓고 적용을 다시 시작하면 밀려 있던 UPDATE 가 정상 적용된다. 건너뛰었다면 그 변경은 영원히 반영되지 않는다.</a:t>
             </a:r>
           </a:p>
         </p:txBody>
@@ -2011,7 +2015,7 @@
           <a:lstStyle/>
           <a:p>
             <a:r>
-              <a:t>모든 이상을 같은 무게로 알리면 아무도 보지 않는다. 14장에서 임계값을 다루며 확인한 것과 같은 원칙이다. 심각은 즉시 사람을 부르고 경고는 근무 시간에 확인하며 주의는 추세만 기록한다. 자동화는 1~3층이 쉽고 14장의 VALIDATE 는 파싱이 번거로워 자주 빠진다. 최소한 Ready for Switchover 한 줄만이라도 grep 으로 뽑아 둔다.</a:t>
+              <a:t>첫 번째가 가장 중요하다. V$DATAGUARD_STATS 는 Primary 에서 no rows 이고, V$STANDBY_LOG 는 Primary 에서 전부 UNASSIGNED 다. 둘 다 오류가 나지 않으므로 같은 스크립트를 양쪽에 돌리면 Primary 에서 조용히 오판한다. V$DATABASE 로 역할을 먼저 판정하고 분기하는 구조여야 하며, 빈 결과와 오류도 구별해 처리해야 한다.</a:t>
             </a:r>
           </a:p>
         </p:txBody>
@@ -2082,6 +2086,216 @@
           <a:p>
             <a:r>
               <a:t>STATUS 에 값이 들어가는 경우는 INVALID, STALE, DELETED 셋뿐이다. 비어 있는 것이 정상이라는 성질은 감시 스크립트에 쓰기 좋다. WHERE status IS NOT NULL 인 행이 하나라도 나오면 확인 대상이라는 조건 하나로 끝난다. ACTIVE 이면서 아카이브되지 않은 그룹이 쌓이는 것은 방치하면 로그 전환 자체가 멈추는 문제로 이어진다.</a:t>
+            </a:r>
+          </a:p>
+        </p:txBody>
+      </p:sp>
+      <p:sp>
+        <p:nvSpPr>
+          <p:cNvPr id="4" name="Slide Number Placeholder 3"/>
+          <p:cNvSpPr>
+            <a:spLocks noGrp="1"/>
+          </p:cNvSpPr>
+          <p:nvPr>
+            <p:ph type="sldNum" idx="5" sz="quarter"/>
+          </p:nvPr>
+        </p:nvSpPr>
+        <p:spPr/>
+      </p:sp>
+    </p:spTree>
+  </p:cSld>
+  <p:clrMapOvr>
+    <a:masterClrMapping/>
+  </p:clrMapOvr>
+</p:notes>
+</file>
+
+<file path=ppt/notesSlides/notesSlide30.xml><?xml version="1.0" encoding="utf-8"?>
+<p:notes xmlns:a="http://schemas.openxmlformats.org/drawingml/2006/main" xmlns:p="http://schemas.openxmlformats.org/presentationml/2006/main" xmlns:r="http://schemas.openxmlformats.org/officeDocument/2006/relationships">
+  <p:cSld>
+    <p:spTree>
+      <p:nvGrpSpPr>
+        <p:cNvPr id="1" name=""/>
+        <p:cNvGrpSpPr/>
+        <p:nvPr/>
+      </p:nvGrpSpPr>
+      <p:grpSpPr>
+        <a:xfrm>
+          <a:off x="0" y="0"/>
+          <a:ext cx="0" cy="0"/>
+          <a:chOff x="0" y="0"/>
+          <a:chExt cx="0" cy="0"/>
+        </a:xfrm>
+      </p:grpSpPr>
+      <p:sp>
+        <p:nvSpPr>
+          <p:cNvPr id="2" name="Slide Image Placeholder 1"/>
+          <p:cNvSpPr>
+            <a:spLocks noGrp="1"/>
+          </p:cNvSpPr>
+          <p:nvPr>
+            <p:ph type="sldImg" idx="2"/>
+          </p:nvPr>
+        </p:nvSpPr>
+        <p:spPr/>
+      </p:sp>
+      <p:sp>
+        <p:nvSpPr>
+          <p:cNvPr id="3" name="Notes Placeholder 2"/>
+          <p:cNvSpPr>
+            <a:spLocks noGrp="1"/>
+          </p:cNvSpPr>
+          <p:nvPr>
+            <p:ph type="body" idx="3" sz="quarter"/>
+          </p:nvPr>
+        </p:nvSpPr>
+        <p:spPr/>
+        <p:txBody>
+          <a:bodyPr/>
+          <a:lstStyle/>
+          <a:p>
+            <a:r>
+              <a:t>boston 의 DG_ERR 가 0 인 것이 의미가 있다. 실습 03 의 오류는 Primary 쪽에만 기록됐다. 보내는 쪽이 실패를 알고 받는 쪽은 모르기 때문이며, 양쪽을 다 봐야 하는 이유가 여기 있다. DG_ERR 에는 시간 조건이 들어 있으므로 한 시간이 지나면 자동으로 0 이 된다. 이 값 하나가 지금 봐야 할 일이 있는가에 답한다. 나머지 항목의 기댓값도 미리 정해 두어야 스크립트가 판정할 수 있다.</a:t>
+            </a:r>
+          </a:p>
+        </p:txBody>
+      </p:sp>
+      <p:sp>
+        <p:nvSpPr>
+          <p:cNvPr id="4" name="Slide Number Placeholder 3"/>
+          <p:cNvSpPr>
+            <a:spLocks noGrp="1"/>
+          </p:cNvSpPr>
+          <p:nvPr>
+            <p:ph type="sldNum" idx="5" sz="quarter"/>
+          </p:nvPr>
+        </p:nvSpPr>
+        <p:spPr/>
+      </p:sp>
+    </p:spTree>
+  </p:cSld>
+  <p:clrMapOvr>
+    <a:masterClrMapping/>
+  </p:clrMapOvr>
+</p:notes>
+</file>
+
+<file path=ppt/notesSlides/notesSlide31.xml><?xml version="1.0" encoding="utf-8"?>
+<p:notes xmlns:a="http://schemas.openxmlformats.org/drawingml/2006/main" xmlns:p="http://schemas.openxmlformats.org/presentationml/2006/main" xmlns:r="http://schemas.openxmlformats.org/officeDocument/2006/relationships">
+  <p:cSld>
+    <p:spTree>
+      <p:nvGrpSpPr>
+        <p:cNvPr id="1" name=""/>
+        <p:cNvGrpSpPr/>
+        <p:nvPr/>
+      </p:nvGrpSpPr>
+      <p:grpSpPr>
+        <a:xfrm>
+          <a:off x="0" y="0"/>
+          <a:ext cx="0" cy="0"/>
+          <a:chOff x="0" y="0"/>
+          <a:chExt cx="0" cy="0"/>
+        </a:xfrm>
+      </p:grpSpPr>
+      <p:sp>
+        <p:nvSpPr>
+          <p:cNvPr id="2" name="Slide Image Placeholder 1"/>
+          <p:cNvSpPr>
+            <a:spLocks noGrp="1"/>
+          </p:cNvSpPr>
+          <p:nvPr>
+            <p:ph type="sldImg" idx="2"/>
+          </p:nvPr>
+        </p:nvSpPr>
+        <p:spPr/>
+      </p:sp>
+      <p:sp>
+        <p:nvSpPr>
+          <p:cNvPr id="3" name="Notes Placeholder 2"/>
+          <p:cNvSpPr>
+            <a:spLocks noGrp="1"/>
+          </p:cNvSpPr>
+          <p:nvPr>
+            <p:ph type="body" idx="3" sz="quarter"/>
+          </p:nvPr>
+        </p:nvSpPr>
+        <p:spPr/>
+        <p:txBody>
+          <a:bodyPr/>
+          <a:lstStyle/>
+          <a:p>
+            <a:r>
+              <a:t>SRL_ACTIVE 가 이 점검표의 핵심이다. 지연이 0 으로 보이는 두 상황 모두에서 ACTIVE 인 SRL 이 사라지므로 이 값 하나가 두 사례를 모두 잡는다. 지연을 버리라는 뜻은 아니다. 흐르고는 있는데 느린 상황은 지연만이 잡는다. 두 종류를 함께 두어야 끊겼다와 느리다를 구별할 수 있고, 그래야 대응의 시급성도 달라진다. 대응의 시급성이 달라지므로 이 구분이 실무에서 중요하다.</a:t>
+            </a:r>
+          </a:p>
+        </p:txBody>
+      </p:sp>
+      <p:sp>
+        <p:nvSpPr>
+          <p:cNvPr id="4" name="Slide Number Placeholder 3"/>
+          <p:cNvSpPr>
+            <a:spLocks noGrp="1"/>
+          </p:cNvSpPr>
+          <p:nvPr>
+            <p:ph type="sldNum" idx="5" sz="quarter"/>
+          </p:nvPr>
+        </p:nvSpPr>
+        <p:spPr/>
+      </p:sp>
+    </p:spTree>
+  </p:cSld>
+  <p:clrMapOvr>
+    <a:masterClrMapping/>
+  </p:clrMapOvr>
+</p:notes>
+</file>
+
+<file path=ppt/notesSlides/notesSlide32.xml><?xml version="1.0" encoding="utf-8"?>
+<p:notes xmlns:a="http://schemas.openxmlformats.org/drawingml/2006/main" xmlns:p="http://schemas.openxmlformats.org/presentationml/2006/main" xmlns:r="http://schemas.openxmlformats.org/officeDocument/2006/relationships">
+  <p:cSld>
+    <p:spTree>
+      <p:nvGrpSpPr>
+        <p:cNvPr id="1" name=""/>
+        <p:cNvGrpSpPr/>
+        <p:nvPr/>
+      </p:nvGrpSpPr>
+      <p:grpSpPr>
+        <a:xfrm>
+          <a:off x="0" y="0"/>
+          <a:ext cx="0" cy="0"/>
+          <a:chOff x="0" y="0"/>
+          <a:chExt cx="0" cy="0"/>
+        </a:xfrm>
+      </p:grpSpPr>
+      <p:sp>
+        <p:nvSpPr>
+          <p:cNvPr id="2" name="Slide Image Placeholder 1"/>
+          <p:cNvSpPr>
+            <a:spLocks noGrp="1"/>
+          </p:cNvSpPr>
+          <p:nvPr>
+            <p:ph type="sldImg" idx="2"/>
+          </p:nvPr>
+        </p:nvSpPr>
+        <p:spPr/>
+      </p:sp>
+      <p:sp>
+        <p:nvSpPr>
+          <p:cNvPr id="3" name="Notes Placeholder 2"/>
+          <p:cNvSpPr>
+            <a:spLocks noGrp="1"/>
+          </p:cNvSpPr>
+          <p:nvPr>
+            <p:ph type="body" idx="3" sz="quarter"/>
+          </p:nvPr>
+        </p:nvSpPr>
+        <p:spPr/>
+        <p:txBody>
+          <a:bodyPr/>
+          <a:lstStyle/>
+          <a:p>
+            <a:r>
+              <a:t>모든 이상을 같은 무게로 알리면 아무도 보지 않는다. 14장에서 임계값을 다루며 확인한 것과 같은 원칙이다. 심각은 즉시 사람을 부르고 경고는 근무 시간에 확인하며 주의는 추세만 기록한다. 자동화는 1~3층이 쉽고 14장의 VALIDATE 는 파싱이 번거로워 자주 빠진다. 최소한 Ready for Switchover 한 줄만이라도 grep 으로 뽑아 둔다.</a:t>
             </a:r>
           </a:p>
         </p:txBody>
@@ -8340,6 +8554,22 @@
                 </a:solidFill>
                 <a:latin typeface="맑은 고딕"/>
               </a:rPr>
+              <a:t>•  Logical Standby 에서 어떤 뷰가 비는지 알고 `V$LOGSTDBY_TRANSACTION` 을 읽는다.</a:t>
+            </a:r>
+          </a:p>
+          <a:p>
+            <a:pPr algn="l">
+              <a:spcAft>
+                <a:spcPts val="1000"/>
+              </a:spcAft>
+            </a:pPr>
+            <a:r>
+              <a:rPr sz="1600" b="0">
+                <a:solidFill>
+                  <a:srgbClr val="222222"/>
+                </a:solidFill>
+                <a:latin typeface="맑은 고딕"/>
+              </a:rPr>
               <a:t>•  지표를 한 번에 수집하는 상시 점검 스크립트를 만든다.</a:t>
             </a:r>
           </a:p>
@@ -10842,7 +11072,23 @@
                 </a:solidFill>
                 <a:latin typeface="맑은 고딕"/>
               </a:rPr>
-              <a:t>•  15.6  상시 점검 스크립트</a:t>
+              <a:t>•  15.6  Logical Standby 는 다른 뷰로 본다</a:t>
+            </a:r>
+          </a:p>
+          <a:p>
+            <a:pPr algn="l">
+              <a:spcAft>
+                <a:spcPts val="1000"/>
+              </a:spcAft>
+            </a:pPr>
+            <a:r>
+              <a:rPr sz="1600" b="0">
+                <a:solidFill>
+                  <a:srgbClr val="222222"/>
+                </a:solidFill>
+                <a:latin typeface="맑은 고딕"/>
+              </a:rPr>
+              <a:t>•  15.7  상시 점검 스크립트</a:t>
             </a:r>
           </a:p>
         </p:txBody>
@@ -11902,7 +12148,7 @@
                 </a:solidFill>
                 <a:latin typeface="맑은 고딕"/>
               </a:rPr>
-              <a:t>상시 점검 스크립트</a:t>
+              <a:t>Logical Standby 는 다른 뷰로 본다</a:t>
             </a:r>
           </a:p>
         </p:txBody>
@@ -11985,7 +12231,7 @@
                 </a:solidFill>
                 <a:latin typeface="맑은 고딕"/>
               </a:rPr>
-              <a:t>•  역할별로 다르다</a:t>
+              <a:t>•  익숙한 뷰가 비어 버린다</a:t>
             </a:r>
           </a:p>
           <a:p>
@@ -12001,23 +12247,7 @@
                 </a:solidFill>
                 <a:latin typeface="맑은 고딕"/>
               </a:rPr>
-              <a:t>•  주 지표와 보조 지표</a:t>
-            </a:r>
-          </a:p>
-          <a:p>
-            <a:pPr algn="l">
-              <a:spcAft>
-                <a:spcPts val="800"/>
-              </a:spcAft>
-            </a:pPr>
-            <a:r>
-              <a:rPr sz="1600" b="0">
-                <a:solidFill>
-                  <a:srgbClr val="FFFFFF"/>
-                </a:solidFill>
-                <a:latin typeface="맑은 고딕"/>
-              </a:rPr>
-              <a:t>•  판정 규칙</a:t>
+              <a:t>•  트랜잭션 단위로 볼 수 있다</a:t>
             </a:r>
           </a:p>
         </p:txBody>
@@ -12118,7 +12348,7 @@
                 </a:solidFill>
                 <a:latin typeface="맑은 고딕"/>
               </a:rPr>
-              <a:t>설계 원칙</a:t>
+              <a:t>뷰가 통째로 빈다</a:t>
             </a:r>
           </a:p>
         </p:txBody>
@@ -12157,7 +12387,7 @@
                 </a:solidFill>
                 <a:latin typeface="맑은 고딕"/>
               </a:rPr>
-              <a:t>다섯 가지</a:t>
+              <a:t>역할이 바뀌면</a:t>
             </a:r>
           </a:p>
         </p:txBody>
@@ -12196,7 +12426,7 @@
                 </a:solidFill>
                 <a:latin typeface="맑은 고딕"/>
               </a:rPr>
-              <a:t>•  **① 역할에 따라 다른 것을 본다**</a:t>
+              <a:t>•  `V$MANAGED_STANDBY` — `ARCH` 4, `DGRD` 2. **`MRP0` 이 없다**</a:t>
             </a:r>
           </a:p>
           <a:p>
@@ -12212,7 +12442,7 @@
                 </a:solidFill>
                 <a:latin typeface="맑은 고딕"/>
               </a:rPr>
-              <a:t>•  ② `count(*)` 로 판정 가능한 숫자를 만든다</a:t>
+              <a:t>•  `V$DATAGUARD_STATS` — **`no rows selected`**</a:t>
             </a:r>
           </a:p>
           <a:p>
@@ -12228,7 +12458,7 @@
                 </a:solidFill>
                 <a:latin typeface="맑은 고딕"/>
               </a:rPr>
-              <a:t>•  ③ 정상값을 미리 정한다</a:t>
+              <a:t>•  두 지연이 아예 없다 — 점검표의 보조 지표가 사라진다</a:t>
             </a:r>
           </a:p>
           <a:p>
@@ -12244,23 +12474,7 @@
                 </a:solidFill>
                 <a:latin typeface="맑은 고딕"/>
               </a:rPr>
-              <a:t>•  ④ `V$DATAGUARD_STATUS` 에는 **시간 조건**을 넣는다</a:t>
-            </a:r>
-          </a:p>
-          <a:p>
-            <a:pPr algn="l">
-              <a:spcAft>
-                <a:spcPts val="1000"/>
-              </a:spcAft>
-            </a:pPr>
-            <a:r>
-              <a:rPr sz="1700" b="0">
-                <a:solidFill>
-                  <a:srgbClr val="222222"/>
-                </a:solidFill>
-                <a:latin typeface="맑은 고딕"/>
-              </a:rPr>
-              <a:t>•  ⑤ 조회 대상을 최소로 한다</a:t>
+              <a:t>•  대신 `V$LOGSTDBY_STATE` 와 `DBA_LOGSTDBY_PROGRESS` 를 본다</a:t>
             </a:r>
           </a:p>
         </p:txBody>
@@ -12361,7 +12575,7 @@
                 </a:solidFill>
                 <a:latin typeface="맑은 고딕"/>
               </a:rPr>
-              <a:t>수집 항목</a:t>
+              <a:t>V$LOGSTDBY_TRANSACTION</a:t>
             </a:r>
           </a:p>
         </p:txBody>
@@ -12400,7 +12614,7 @@
                 </a:solidFill>
                 <a:latin typeface="맑은 고딕"/>
               </a:rPr>
-              <a:t>Primary / Standby</a:t>
+              <a:t>열 이름부터 다르다</a:t>
             </a:r>
           </a:p>
         </p:txBody>
@@ -12439,7 +12653,7 @@
                 </a:solidFill>
                 <a:latin typeface="맑은 고딕"/>
               </a:rPr>
-              <a:t>•  Primary — 목적지 `STATUS`, `LOG_ABNORMAL`, `DG_ERR`, `CUR_SEQ`</a:t>
+              <a:t>•  `XIDUSN` 으로 조회하면 **`ORA-00904`**</a:t>
             </a:r>
           </a:p>
           <a:p>
@@ -12455,7 +12669,7 @@
                 </a:solidFill>
                 <a:latin typeface="맑은 고딕"/>
               </a:rPr>
-              <a:t>•  Standby — `MRP0`, `SEQUENCE#`, `RECOVERY_MODE`</a:t>
+              <a:t>•  실제 열은 전부 **`PRIMARY_` 접두어** — `PRIMARY_XIDUSN` …</a:t>
             </a:r>
           </a:p>
           <a:p>
@@ -12471,7 +12685,7 @@
                 </a:solidFill>
                 <a:latin typeface="맑은 고딕"/>
               </a:rPr>
-              <a:t>•  Standby — **`SRL_ACTIVE`**, `GAP_CNT`, `DG_ERR`</a:t>
+              <a:t>•  `SAVEPOINT_SCN` · `COMMIT_SCN` 은 19c 에 **없다**</a:t>
             </a:r>
           </a:p>
           <a:p>
@@ -12487,7 +12701,7 @@
                 </a:solidFill>
                 <a:latin typeface="맑은 고딕"/>
               </a:rPr>
-              <a:t>•  실측 `DG_ERR` chicago **3**(실습 03 흔적) / boston **0**</a:t>
+              <a:t>•  실측 — `XID 9.9.821 | DML | MINING COMPLETE | APPLY NONE | SRC_CON 3`</a:t>
             </a:r>
           </a:p>
         </p:txBody>
@@ -12588,7 +12802,7 @@
                 </a:solidFill>
                 <a:latin typeface="맑은 고딕"/>
               </a:rPr>
-              <a:t>주 지표와 보조 지표</a:t>
+              <a:t>멈추면 이 뷰가 답하지 않는다</a:t>
             </a:r>
           </a:p>
         </p:txBody>
@@ -12627,7 +12841,7 @@
                 </a:solidFill>
                 <a:latin typeface="맑은 고딕"/>
               </a:rPr>
-              <a:t>지연을 믿지 않는다</a:t>
+              <a:t>XID 는 어디서 찾는가</a:t>
             </a:r>
           </a:p>
         </p:txBody>
@@ -12666,7 +12880,7 @@
                 </a:solidFill>
                 <a:latin typeface="맑은 고딕"/>
               </a:rPr>
-              <a:t>•  **주 지표** — `SRL_ACTIVE`=1, `MRP0` 존재, 두 `SEQUENCE#` 일치, `STATUS`=VALID</a:t>
+              <a:t>•  적용이 멈추면 `V$LOGSTDBY_TRANSACTION` 은 **비어 버린다**</a:t>
             </a:r>
           </a:p>
           <a:p>
@@ -12682,7 +12896,7 @@
                 </a:solidFill>
                 <a:latin typeface="맑은 고딕"/>
               </a:rPr>
-              <a:t>•  **보조 지표** — `transport lag`, `apply lag`</a:t>
+              <a:t>•  멈춘 뒤의 XID 는 `DBA_LOGSTDBY_EVENTS` 에 — 열 이름은 `XIDUSN`</a:t>
             </a:r>
           </a:p>
           <a:p>
@@ -12698,7 +12912,7 @@
                 </a:solidFill>
                 <a:latin typeface="맑은 고딕"/>
               </a:rPr>
-              <a:t>•  지연은 **두 번 모두 0** 이었다 (14장 속성, 15장 리스너)</a:t>
+              <a:t>•  실측 오류 **`ORA-26787`** (그 키의 행이 표에 없다)</a:t>
             </a:r>
           </a:p>
           <a:p>
@@ -12714,7 +12928,7 @@
                 </a:solidFill>
                 <a:latin typeface="맑은 고딕"/>
               </a:rPr>
-              <a:t>•  주 지표가 무너지면 **끊긴** 것, 보조만 나쁘면 **느린** 것</a:t>
+              <a:t>•  `SKIP_TRANSACTION` — PDB 에서 `ORA-65040`, 정지 상태에서 `ORA-16104`</a:t>
             </a:r>
           </a:p>
         </p:txBody>
@@ -12746,7 +12960,7 @@
         <p:spPr>
           <a:xfrm>
             <a:off x="0" y="0"/>
-            <a:ext cx="12191695" cy="1005840"/>
+            <a:ext cx="12191695" cy="6858000"/>
           </a:xfrm>
           <a:prstGeom prst="rect">
             <a:avLst/>
@@ -12789,8 +13003,8 @@
         </p:nvSpPr>
         <p:spPr>
           <a:xfrm>
-            <a:off x="548640" y="91440"/>
-            <a:ext cx="10972800" cy="777240"/>
+            <a:off x="822960" y="2011680"/>
+            <a:ext cx="10515600" cy="1097280"/>
           </a:xfrm>
           <a:prstGeom prst="rect">
             <a:avLst/>
@@ -12809,13 +13023,13 @@
               </a:spcAft>
             </a:pPr>
             <a:r>
-              <a:rPr sz="2600" b="1">
+              <a:rPr sz="4000" b="1">
                 <a:solidFill>
                   <a:srgbClr val="FFFFFF"/>
                 </a:solidFill>
                 <a:latin typeface="맑은 고딕"/>
               </a:rPr>
-              <a:t>판정 규칙</a:t>
+              <a:t>15.7</a:t>
             </a:r>
           </a:p>
         </p:txBody>
@@ -12828,8 +13042,8 @@
         </p:nvSpPr>
         <p:spPr>
           <a:xfrm>
-            <a:off x="640080" y="1078992"/>
-            <a:ext cx="10881360" cy="457200"/>
+            <a:off x="822960" y="3017520"/>
+            <a:ext cx="10515600" cy="914400"/>
           </a:xfrm>
           <a:prstGeom prst="rect">
             <a:avLst/>
@@ -12848,27 +13062,71 @@
               </a:spcAft>
             </a:pPr>
             <a:r>
-              <a:rPr sz="1500" b="0">
-                <a:solidFill>
-                  <a:srgbClr val="5A6672"/>
-                </a:solidFill>
-                <a:latin typeface="맑은 고딕"/>
-              </a:rPr>
-              <a:t>네 단계</a:t>
-            </a:r>
-          </a:p>
-        </p:txBody>
-      </p:sp>
-      <p:sp>
-        <p:nvSpPr>
-          <p:cNvPr id="5" name="TextBox 4"/>
+              <a:rPr sz="2800" b="1">
+                <a:solidFill>
+                  <a:srgbClr val="FFFFFF"/>
+                </a:solidFill>
+                <a:latin typeface="맑은 고딕"/>
+              </a:rPr>
+              <a:t>상시 점검 스크립트</a:t>
+            </a:r>
+          </a:p>
+        </p:txBody>
+      </p:sp>
+      <p:sp>
+        <p:nvSpPr>
+          <p:cNvPr id="5" name="Rectangle 4"/>
+          <p:cNvSpPr/>
+          <p:nvPr/>
+        </p:nvSpPr>
+        <p:spPr>
+          <a:xfrm>
+            <a:off x="822960" y="4114800"/>
+            <a:ext cx="5486400" cy="54864"/>
+          </a:xfrm>
+          <a:prstGeom prst="rect">
+            <a:avLst/>
+          </a:prstGeom>
+          <a:solidFill>
+            <a:srgbClr val="FFFFFF"/>
+          </a:solidFill>
+          <a:ln>
+            <a:noFill/>
+          </a:ln>
+          <a:effectLst/>
+        </p:spPr>
+        <p:style>
+          <a:lnRef idx="1">
+            <a:schemeClr val="accent1"/>
+          </a:lnRef>
+          <a:fillRef idx="3">
+            <a:schemeClr val="accent1"/>
+          </a:fillRef>
+          <a:effectRef idx="2">
+            <a:schemeClr val="accent1"/>
+          </a:effectRef>
+          <a:fontRef idx="minor">
+            <a:schemeClr val="lt1"/>
+          </a:fontRef>
+        </p:style>
+        <p:txBody>
+          <a:bodyPr rtlCol="0" anchor="ctr"/>
+          <a:lstStyle/>
+          <a:p>
+            <a:pPr algn="ctr"/>
+          </a:p>
+        </p:txBody>
+      </p:sp>
+      <p:sp>
+        <p:nvSpPr>
+          <p:cNvPr id="6" name="TextBox 5"/>
           <p:cNvSpPr txBox="1"/>
           <p:nvPr/>
         </p:nvSpPr>
         <p:spPr>
           <a:xfrm>
-            <a:off x="640080" y="1737360"/>
-            <a:ext cx="10881360" cy="4754880"/>
+            <a:off x="822960" y="4297680"/>
+            <a:ext cx="10058400" cy="2011680"/>
           </a:xfrm>
           <a:prstGeom prst="rect">
             <a:avLst/>
@@ -12883,65 +13141,49 @@
           <a:p>
             <a:pPr algn="l">
               <a:spcAft>
-                <a:spcPts val="1000"/>
-              </a:spcAft>
-            </a:pPr>
-            <a:r>
-              <a:rPr sz="1700" b="0">
-                <a:solidFill>
-                  <a:srgbClr val="222222"/>
-                </a:solidFill>
-                <a:latin typeface="맑은 고딕"/>
-              </a:rPr>
-              <a:t>•  **정상** — 모든 기댓값과 일치</a:t>
-            </a:r>
-          </a:p>
-          <a:p>
-            <a:pPr algn="l">
-              <a:spcAft>
-                <a:spcPts val="1000"/>
-              </a:spcAft>
-            </a:pPr>
-            <a:r>
-              <a:rPr sz="1700" b="0">
-                <a:solidFill>
-                  <a:srgbClr val="222222"/>
-                </a:solidFill>
-                <a:latin typeface="맑은 고딕"/>
-              </a:rPr>
-              <a:t>•  **주의** — 지연이 임계값 초과 (`SRL_ACTIVE=1` 인 상태)</a:t>
-            </a:r>
-          </a:p>
-          <a:p>
-            <a:pPr algn="l">
-              <a:spcAft>
-                <a:spcPts val="1000"/>
-              </a:spcAft>
-            </a:pPr>
-            <a:r>
-              <a:rPr sz="1700" b="0">
-                <a:solidFill>
-                  <a:srgbClr val="222222"/>
-                </a:solidFill>
-                <a:latin typeface="맑은 고딕"/>
-              </a:rPr>
-              <a:t>•  **경고** — `DG_ERR&gt;0` 또는 `SEQUENCE#` 차이 2 이상</a:t>
-            </a:r>
-          </a:p>
-          <a:p>
-            <a:pPr algn="l">
-              <a:spcAft>
-                <a:spcPts val="1000"/>
-              </a:spcAft>
-            </a:pPr>
-            <a:r>
-              <a:rPr sz="1700" b="0">
-                <a:solidFill>
-                  <a:srgbClr val="222222"/>
-                </a:solidFill>
-                <a:latin typeface="맑은 고딕"/>
-              </a:rPr>
-              <a:t>•  **심각** — `SRL_ACTIVE=0` / `MRP0` 없음 / `STATUS='ERROR'`</a:t>
+                <a:spcPts val="800"/>
+              </a:spcAft>
+            </a:pPr>
+            <a:r>
+              <a:rPr sz="1600" b="0">
+                <a:solidFill>
+                  <a:srgbClr val="FFFFFF"/>
+                </a:solidFill>
+                <a:latin typeface="맑은 고딕"/>
+              </a:rPr>
+              <a:t>•  역할별로 다르다</a:t>
+            </a:r>
+          </a:p>
+          <a:p>
+            <a:pPr algn="l">
+              <a:spcAft>
+                <a:spcPts val="800"/>
+              </a:spcAft>
+            </a:pPr>
+            <a:r>
+              <a:rPr sz="1600" b="0">
+                <a:solidFill>
+                  <a:srgbClr val="FFFFFF"/>
+                </a:solidFill>
+                <a:latin typeface="맑은 고딕"/>
+              </a:rPr>
+              <a:t>•  주 지표와 보조 지표</a:t>
+            </a:r>
+          </a:p>
+          <a:p>
+            <a:pPr algn="l">
+              <a:spcAft>
+                <a:spcPts val="800"/>
+              </a:spcAft>
+            </a:pPr>
+            <a:r>
+              <a:rPr sz="1600" b="0">
+                <a:solidFill>
+                  <a:srgbClr val="FFFFFF"/>
+                </a:solidFill>
+                <a:latin typeface="맑은 고딕"/>
+              </a:rPr>
+              <a:t>•  판정 규칙</a:t>
             </a:r>
           </a:p>
         </p:txBody>
@@ -13042,7 +13284,7 @@
                 </a:solidFill>
                 <a:latin typeface="맑은 고딕"/>
               </a:rPr>
-              <a:t>요약</a:t>
+              <a:t>설계 원칙</a:t>
             </a:r>
           </a:p>
         </p:txBody>
@@ -13055,8 +13297,8 @@
         </p:nvSpPr>
         <p:spPr>
           <a:xfrm>
-            <a:off x="640080" y="1371600"/>
-            <a:ext cx="10881360" cy="5120640"/>
+            <a:off x="640080" y="1078992"/>
+            <a:ext cx="10881360" cy="457200"/>
           </a:xfrm>
           <a:prstGeom prst="rect">
             <a:avLst/>
@@ -13071,17 +13313,56 @@
           <a:p>
             <a:pPr algn="l">
               <a:spcAft>
+                <a:spcPts val="600"/>
+              </a:spcAft>
+            </a:pPr>
+            <a:r>
+              <a:rPr sz="1500" b="0">
+                <a:solidFill>
+                  <a:srgbClr val="5A6672"/>
+                </a:solidFill>
+                <a:latin typeface="맑은 고딕"/>
+              </a:rPr>
+              <a:t>다섯 가지</a:t>
+            </a:r>
+          </a:p>
+        </p:txBody>
+      </p:sp>
+      <p:sp>
+        <p:nvSpPr>
+          <p:cNvPr id="5" name="TextBox 4"/>
+          <p:cNvSpPr txBox="1"/>
+          <p:nvPr/>
+        </p:nvSpPr>
+        <p:spPr>
+          <a:xfrm>
+            <a:off x="640080" y="1737360"/>
+            <a:ext cx="10881360" cy="4754880"/>
+          </a:xfrm>
+          <a:prstGeom prst="rect">
+            <a:avLst/>
+          </a:prstGeom>
+          <a:noFill/>
+        </p:spPr>
+        <p:txBody>
+          <a:bodyPr wrap="square">
+            <a:spAutoFit/>
+          </a:bodyPr>
+          <a:lstStyle/>
+          <a:p>
+            <a:pPr algn="l">
+              <a:spcAft>
                 <a:spcPts val="1000"/>
               </a:spcAft>
             </a:pPr>
             <a:r>
-              <a:rPr sz="1600" b="0">
+              <a:rPr sz="1700" b="0">
                 <a:solidFill>
                   <a:srgbClr val="222222"/>
                 </a:solidFill>
                 <a:latin typeface="맑은 고딕"/>
               </a:rPr>
-              <a:t>•  Standby 의 온라인 리두는 `SEQUENCE#`가 0, Primary 의 SRL 은 전부 `UNASSIGNED`</a:t>
+              <a:t>•  **① 역할에 따라 다른 것을 본다**</a:t>
             </a:r>
           </a:p>
           <a:p>
@@ -13091,13 +13372,13 @@
               </a:spcAft>
             </a:pPr>
             <a:r>
-              <a:rPr sz="1600" b="0">
+              <a:rPr sz="1700" b="0">
                 <a:solidFill>
                   <a:srgbClr val="222222"/>
                 </a:solidFill>
                 <a:latin typeface="맑은 고딕"/>
               </a:rPr>
-              <a:t>•  SRL 은 **`ACTIVE` 가 정확히 하나**이고 시퀀스가 Primary 와 같아야 한다</a:t>
+              <a:t>•  ② `count(*)` 로 판정 가능한 숫자를 만든다</a:t>
             </a:r>
           </a:p>
           <a:p>
@@ -13107,13 +13388,13 @@
               </a:spcAft>
             </a:pPr>
             <a:r>
-              <a:rPr sz="1600" b="0">
+              <a:rPr sz="1700" b="0">
                 <a:solidFill>
                   <a:srgbClr val="222222"/>
                 </a:solidFill>
                 <a:latin typeface="맑은 고딕"/>
               </a:rPr>
-              <a:t>•  `V$ARCHIVE_DEST` 는 설정, `_STATUS` 는 지금 상태</a:t>
+              <a:t>•  ③ 정상값을 미리 정한다</a:t>
             </a:r>
           </a:p>
           <a:p>
@@ -13123,13 +13404,13 @@
               </a:spcAft>
             </a:pPr>
             <a:r>
-              <a:rPr sz="1600" b="0">
+              <a:rPr sz="1700" b="0">
                 <a:solidFill>
                   <a:srgbClr val="222222"/>
                 </a:solidFill>
                 <a:latin typeface="맑은 고딕"/>
               </a:rPr>
-              <a:t>•  `V$ARCHIVED_LOG` 의 `APPLIED` 는 **`dest_id=2`만** 의미가 있다</a:t>
+              <a:t>•  ④ `V$DATAGUARD_STATUS` 에는 **시간 조건**을 넣는다</a:t>
             </a:r>
           </a:p>
           <a:p>
@@ -13139,141 +13420,13 @@
               </a:spcAft>
             </a:pPr>
             <a:r>
-              <a:rPr sz="1600" b="0">
+              <a:rPr sz="1700" b="0">
                 <a:solidFill>
                   <a:srgbClr val="222222"/>
                 </a:solidFill>
                 <a:latin typeface="맑은 고딕"/>
               </a:rPr>
-              <a:t>•  `APPLIED_SEQ#`=0 은 정상 — 실시간 적용은 SRL 에서 읽는다</a:t>
-            </a:r>
-          </a:p>
-          <a:p>
-            <a:pPr algn="l">
-              <a:spcAft>
-                <a:spcPts val="1000"/>
-              </a:spcAft>
-            </a:pPr>
-            <a:r>
-              <a:rPr sz="1600" b="0">
-                <a:solidFill>
-                  <a:srgbClr val="222222"/>
-                </a:solidFill>
-                <a:latin typeface="맑은 고딕"/>
-              </a:rPr>
-              <a:t>•  리스너를 내리면 `ERROR` / `INACTIVE` / **`ORA-12541`**</a:t>
-            </a:r>
-          </a:p>
-          <a:p>
-            <a:pPr algn="l">
-              <a:spcAft>
-                <a:spcPts val="1000"/>
-              </a:spcAft>
-            </a:pPr>
-            <a:r>
-              <a:rPr sz="1600" b="0">
-                <a:solidFill>
-                  <a:srgbClr val="222222"/>
-                </a:solidFill>
-                <a:latin typeface="맑은 고딕"/>
-              </a:rPr>
-              <a:t>•  그때도 **두 지연은 0** — 세 번째로 확인</a:t>
-            </a:r>
-          </a:p>
-          <a:p>
-            <a:pPr algn="l">
-              <a:spcAft>
-                <a:spcPts val="1000"/>
-              </a:spcAft>
-            </a:pPr>
-            <a:r>
-              <a:rPr sz="1600" b="0">
-                <a:solidFill>
-                  <a:srgbClr val="222222"/>
-                </a:solidFill>
-                <a:latin typeface="맑은 고딕"/>
-              </a:rPr>
-              <a:t>•  `ENABLE`+`ERROR`=장애, `RESET`=Broker, `DEFER`=사람</a:t>
-            </a:r>
-          </a:p>
-          <a:p>
-            <a:pPr algn="l">
-              <a:spcAft>
-                <a:spcPts val="1000"/>
-              </a:spcAft>
-            </a:pPr>
-            <a:r>
-              <a:rPr sz="1600" b="0">
-                <a:solidFill>
-                  <a:srgbClr val="222222"/>
-                </a:solidFill>
-                <a:latin typeface="맑은 고딕"/>
-              </a:rPr>
-              <a:t>•  판정 기준은 `SEVERITY` 가 아니라 **`ERROR_CODE`**</a:t>
-            </a:r>
-          </a:p>
-          <a:p>
-            <a:pPr algn="l">
-              <a:spcAft>
-                <a:spcPts val="1000"/>
-              </a:spcAft>
-            </a:pPr>
-            <a:r>
-              <a:rPr sz="1600" b="0">
-                <a:solidFill>
-                  <a:srgbClr val="222222"/>
-                </a:solidFill>
-                <a:latin typeface="맑은 고딕"/>
-              </a:rPr>
-              <a:t>•  복구까지 **약 4~5분** (`ReopenSecs` 300)</a:t>
-            </a:r>
-          </a:p>
-          <a:p>
-            <a:pPr algn="l">
-              <a:spcAft>
-                <a:spcPts val="1000"/>
-              </a:spcAft>
-            </a:pPr>
-            <a:r>
-              <a:rPr sz="1600" b="0">
-                <a:solidFill>
-                  <a:srgbClr val="222222"/>
-                </a:solidFill>
-                <a:latin typeface="맑은 고딕"/>
-              </a:rPr>
-              <a:t>•  조치 직후 Broker 가 `ERROR` 인 것은 **판정 시차**</a:t>
-            </a:r>
-          </a:p>
-          <a:p>
-            <a:pPr algn="l">
-              <a:spcAft>
-                <a:spcPts val="1000"/>
-              </a:spcAft>
-            </a:pPr>
-            <a:r>
-              <a:rPr sz="1600" b="0">
-                <a:solidFill>
-                  <a:srgbClr val="222222"/>
-                </a:solidFill>
-                <a:latin typeface="맑은 고딕"/>
-              </a:rPr>
-              <a:t>•  `LOG_ARCHIVE_TRACE` 는 비트마스크, 잘못된 값은 **ORA-02017**</a:t>
-            </a:r>
-          </a:p>
-          <a:p>
-            <a:pPr algn="l">
-              <a:spcAft>
-                <a:spcPts val="1000"/>
-              </a:spcAft>
-            </a:pPr>
-            <a:r>
-              <a:rPr sz="1600" b="0">
-                <a:solidFill>
-                  <a:srgbClr val="222222"/>
-                </a:solidFill>
-                <a:latin typeface="맑은 고딕"/>
-              </a:rPr>
-              <a:t>•  점검표의 핵심은 **`SRL_ACTIVE`**, 지연은 보조 지표</a:t>
+              <a:t>•  ⑤ 조회 대상을 최소로 한다</a:t>
             </a:r>
           </a:p>
         </p:txBody>
@@ -13526,6 +13679,1051 @@
 </file>
 
 <file path=ppt/slides/slide40.xml><?xml version="1.0" encoding="utf-8"?>
+<p:sld xmlns:a="http://schemas.openxmlformats.org/drawingml/2006/main" xmlns:p="http://schemas.openxmlformats.org/presentationml/2006/main" xmlns:r="http://schemas.openxmlformats.org/officeDocument/2006/relationships">
+  <p:cSld>
+    <p:spTree>
+      <p:nvGrpSpPr>
+        <p:cNvPr id="1" name=""/>
+        <p:cNvGrpSpPr/>
+        <p:nvPr/>
+      </p:nvGrpSpPr>
+      <p:grpSpPr/>
+      <p:sp>
+        <p:nvSpPr>
+          <p:cNvPr id="2" name="Rectangle 1"/>
+          <p:cNvSpPr/>
+          <p:nvPr/>
+        </p:nvSpPr>
+        <p:spPr>
+          <a:xfrm>
+            <a:off x="0" y="0"/>
+            <a:ext cx="12191695" cy="1005840"/>
+          </a:xfrm>
+          <a:prstGeom prst="rect">
+            <a:avLst/>
+          </a:prstGeom>
+          <a:solidFill>
+            <a:srgbClr val="C0392B"/>
+          </a:solidFill>
+          <a:ln>
+            <a:noFill/>
+          </a:ln>
+          <a:effectLst/>
+        </p:spPr>
+        <p:style>
+          <a:lnRef idx="1">
+            <a:schemeClr val="accent1"/>
+          </a:lnRef>
+          <a:fillRef idx="3">
+            <a:schemeClr val="accent1"/>
+          </a:fillRef>
+          <a:effectRef idx="2">
+            <a:schemeClr val="accent1"/>
+          </a:effectRef>
+          <a:fontRef idx="minor">
+            <a:schemeClr val="lt1"/>
+          </a:fontRef>
+        </p:style>
+        <p:txBody>
+          <a:bodyPr rtlCol="0" anchor="ctr"/>
+          <a:lstStyle/>
+          <a:p>
+            <a:pPr algn="ctr"/>
+          </a:p>
+        </p:txBody>
+      </p:sp>
+      <p:sp>
+        <p:nvSpPr>
+          <p:cNvPr id="3" name="TextBox 2"/>
+          <p:cNvSpPr txBox="1"/>
+          <p:nvPr/>
+        </p:nvSpPr>
+        <p:spPr>
+          <a:xfrm>
+            <a:off x="548640" y="91440"/>
+            <a:ext cx="10972800" cy="777240"/>
+          </a:xfrm>
+          <a:prstGeom prst="rect">
+            <a:avLst/>
+          </a:prstGeom>
+          <a:noFill/>
+        </p:spPr>
+        <p:txBody>
+          <a:bodyPr wrap="square">
+            <a:spAutoFit/>
+          </a:bodyPr>
+          <a:lstStyle/>
+          <a:p>
+            <a:pPr algn="l">
+              <a:spcAft>
+                <a:spcPts val="600"/>
+              </a:spcAft>
+            </a:pPr>
+            <a:r>
+              <a:rPr sz="2600" b="1">
+                <a:solidFill>
+                  <a:srgbClr val="FFFFFF"/>
+                </a:solidFill>
+                <a:latin typeface="맑은 고딕"/>
+              </a:rPr>
+              <a:t>수집 항목</a:t>
+            </a:r>
+          </a:p>
+        </p:txBody>
+      </p:sp>
+      <p:sp>
+        <p:nvSpPr>
+          <p:cNvPr id="4" name="TextBox 3"/>
+          <p:cNvSpPr txBox="1"/>
+          <p:nvPr/>
+        </p:nvSpPr>
+        <p:spPr>
+          <a:xfrm>
+            <a:off x="640080" y="1078992"/>
+            <a:ext cx="10881360" cy="457200"/>
+          </a:xfrm>
+          <a:prstGeom prst="rect">
+            <a:avLst/>
+          </a:prstGeom>
+          <a:noFill/>
+        </p:spPr>
+        <p:txBody>
+          <a:bodyPr wrap="square">
+            <a:spAutoFit/>
+          </a:bodyPr>
+          <a:lstStyle/>
+          <a:p>
+            <a:pPr algn="l">
+              <a:spcAft>
+                <a:spcPts val="600"/>
+              </a:spcAft>
+            </a:pPr>
+            <a:r>
+              <a:rPr sz="1500" b="0">
+                <a:solidFill>
+                  <a:srgbClr val="5A6672"/>
+                </a:solidFill>
+                <a:latin typeface="맑은 고딕"/>
+              </a:rPr>
+              <a:t>Primary / Standby</a:t>
+            </a:r>
+          </a:p>
+        </p:txBody>
+      </p:sp>
+      <p:sp>
+        <p:nvSpPr>
+          <p:cNvPr id="5" name="TextBox 4"/>
+          <p:cNvSpPr txBox="1"/>
+          <p:nvPr/>
+        </p:nvSpPr>
+        <p:spPr>
+          <a:xfrm>
+            <a:off x="640080" y="1737360"/>
+            <a:ext cx="10881360" cy="4754880"/>
+          </a:xfrm>
+          <a:prstGeom prst="rect">
+            <a:avLst/>
+          </a:prstGeom>
+          <a:noFill/>
+        </p:spPr>
+        <p:txBody>
+          <a:bodyPr wrap="square">
+            <a:spAutoFit/>
+          </a:bodyPr>
+          <a:lstStyle/>
+          <a:p>
+            <a:pPr algn="l">
+              <a:spcAft>
+                <a:spcPts val="1000"/>
+              </a:spcAft>
+            </a:pPr>
+            <a:r>
+              <a:rPr sz="1700" b="0">
+                <a:solidFill>
+                  <a:srgbClr val="222222"/>
+                </a:solidFill>
+                <a:latin typeface="맑은 고딕"/>
+              </a:rPr>
+              <a:t>•  Primary — 목적지 `STATUS`, `LOG_ABNORMAL`, `DG_ERR`, `CUR_SEQ`</a:t>
+            </a:r>
+          </a:p>
+          <a:p>
+            <a:pPr algn="l">
+              <a:spcAft>
+                <a:spcPts val="1000"/>
+              </a:spcAft>
+            </a:pPr>
+            <a:r>
+              <a:rPr sz="1700" b="0">
+                <a:solidFill>
+                  <a:srgbClr val="222222"/>
+                </a:solidFill>
+                <a:latin typeface="맑은 고딕"/>
+              </a:rPr>
+              <a:t>•  Standby — `MRP0`, `SEQUENCE#`, `RECOVERY_MODE`</a:t>
+            </a:r>
+          </a:p>
+          <a:p>
+            <a:pPr algn="l">
+              <a:spcAft>
+                <a:spcPts val="1000"/>
+              </a:spcAft>
+            </a:pPr>
+            <a:r>
+              <a:rPr sz="1700" b="0">
+                <a:solidFill>
+                  <a:srgbClr val="222222"/>
+                </a:solidFill>
+                <a:latin typeface="맑은 고딕"/>
+              </a:rPr>
+              <a:t>•  Standby — **`SRL_ACTIVE`**, `GAP_CNT`, `DG_ERR`</a:t>
+            </a:r>
+          </a:p>
+          <a:p>
+            <a:pPr algn="l">
+              <a:spcAft>
+                <a:spcPts val="1000"/>
+              </a:spcAft>
+            </a:pPr>
+            <a:r>
+              <a:rPr sz="1700" b="0">
+                <a:solidFill>
+                  <a:srgbClr val="222222"/>
+                </a:solidFill>
+                <a:latin typeface="맑은 고딕"/>
+              </a:rPr>
+              <a:t>•  실측 `DG_ERR` chicago **3**(실습 03 흔적) / boston **0**</a:t>
+            </a:r>
+          </a:p>
+        </p:txBody>
+      </p:sp>
+    </p:spTree>
+  </p:cSld>
+  <p:clrMapOvr>
+    <a:masterClrMapping/>
+  </p:clrMapOvr>
+</p:sld>
+</file>
+
+<file path=ppt/slides/slide41.xml><?xml version="1.0" encoding="utf-8"?>
+<p:sld xmlns:a="http://schemas.openxmlformats.org/drawingml/2006/main" xmlns:p="http://schemas.openxmlformats.org/presentationml/2006/main" xmlns:r="http://schemas.openxmlformats.org/officeDocument/2006/relationships">
+  <p:cSld>
+    <p:spTree>
+      <p:nvGrpSpPr>
+        <p:cNvPr id="1" name=""/>
+        <p:cNvGrpSpPr/>
+        <p:nvPr/>
+      </p:nvGrpSpPr>
+      <p:grpSpPr/>
+      <p:sp>
+        <p:nvSpPr>
+          <p:cNvPr id="2" name="Rectangle 1"/>
+          <p:cNvSpPr/>
+          <p:nvPr/>
+        </p:nvSpPr>
+        <p:spPr>
+          <a:xfrm>
+            <a:off x="0" y="0"/>
+            <a:ext cx="12191695" cy="1005840"/>
+          </a:xfrm>
+          <a:prstGeom prst="rect">
+            <a:avLst/>
+          </a:prstGeom>
+          <a:solidFill>
+            <a:srgbClr val="C0392B"/>
+          </a:solidFill>
+          <a:ln>
+            <a:noFill/>
+          </a:ln>
+          <a:effectLst/>
+        </p:spPr>
+        <p:style>
+          <a:lnRef idx="1">
+            <a:schemeClr val="accent1"/>
+          </a:lnRef>
+          <a:fillRef idx="3">
+            <a:schemeClr val="accent1"/>
+          </a:fillRef>
+          <a:effectRef idx="2">
+            <a:schemeClr val="accent1"/>
+          </a:effectRef>
+          <a:fontRef idx="minor">
+            <a:schemeClr val="lt1"/>
+          </a:fontRef>
+        </p:style>
+        <p:txBody>
+          <a:bodyPr rtlCol="0" anchor="ctr"/>
+          <a:lstStyle/>
+          <a:p>
+            <a:pPr algn="ctr"/>
+          </a:p>
+        </p:txBody>
+      </p:sp>
+      <p:sp>
+        <p:nvSpPr>
+          <p:cNvPr id="3" name="TextBox 2"/>
+          <p:cNvSpPr txBox="1"/>
+          <p:nvPr/>
+        </p:nvSpPr>
+        <p:spPr>
+          <a:xfrm>
+            <a:off x="548640" y="91440"/>
+            <a:ext cx="10972800" cy="777240"/>
+          </a:xfrm>
+          <a:prstGeom prst="rect">
+            <a:avLst/>
+          </a:prstGeom>
+          <a:noFill/>
+        </p:spPr>
+        <p:txBody>
+          <a:bodyPr wrap="square">
+            <a:spAutoFit/>
+          </a:bodyPr>
+          <a:lstStyle/>
+          <a:p>
+            <a:pPr algn="l">
+              <a:spcAft>
+                <a:spcPts val="600"/>
+              </a:spcAft>
+            </a:pPr>
+            <a:r>
+              <a:rPr sz="2600" b="1">
+                <a:solidFill>
+                  <a:srgbClr val="FFFFFF"/>
+                </a:solidFill>
+                <a:latin typeface="맑은 고딕"/>
+              </a:rPr>
+              <a:t>주 지표와 보조 지표</a:t>
+            </a:r>
+          </a:p>
+        </p:txBody>
+      </p:sp>
+      <p:sp>
+        <p:nvSpPr>
+          <p:cNvPr id="4" name="TextBox 3"/>
+          <p:cNvSpPr txBox="1"/>
+          <p:nvPr/>
+        </p:nvSpPr>
+        <p:spPr>
+          <a:xfrm>
+            <a:off x="640080" y="1078992"/>
+            <a:ext cx="10881360" cy="457200"/>
+          </a:xfrm>
+          <a:prstGeom prst="rect">
+            <a:avLst/>
+          </a:prstGeom>
+          <a:noFill/>
+        </p:spPr>
+        <p:txBody>
+          <a:bodyPr wrap="square">
+            <a:spAutoFit/>
+          </a:bodyPr>
+          <a:lstStyle/>
+          <a:p>
+            <a:pPr algn="l">
+              <a:spcAft>
+                <a:spcPts val="600"/>
+              </a:spcAft>
+            </a:pPr>
+            <a:r>
+              <a:rPr sz="1500" b="0">
+                <a:solidFill>
+                  <a:srgbClr val="5A6672"/>
+                </a:solidFill>
+                <a:latin typeface="맑은 고딕"/>
+              </a:rPr>
+              <a:t>지연을 믿지 않는다</a:t>
+            </a:r>
+          </a:p>
+        </p:txBody>
+      </p:sp>
+      <p:sp>
+        <p:nvSpPr>
+          <p:cNvPr id="5" name="TextBox 4"/>
+          <p:cNvSpPr txBox="1"/>
+          <p:nvPr/>
+        </p:nvSpPr>
+        <p:spPr>
+          <a:xfrm>
+            <a:off x="640080" y="1737360"/>
+            <a:ext cx="10881360" cy="4754880"/>
+          </a:xfrm>
+          <a:prstGeom prst="rect">
+            <a:avLst/>
+          </a:prstGeom>
+          <a:noFill/>
+        </p:spPr>
+        <p:txBody>
+          <a:bodyPr wrap="square">
+            <a:spAutoFit/>
+          </a:bodyPr>
+          <a:lstStyle/>
+          <a:p>
+            <a:pPr algn="l">
+              <a:spcAft>
+                <a:spcPts val="1000"/>
+              </a:spcAft>
+            </a:pPr>
+            <a:r>
+              <a:rPr sz="1700" b="0">
+                <a:solidFill>
+                  <a:srgbClr val="222222"/>
+                </a:solidFill>
+                <a:latin typeface="맑은 고딕"/>
+              </a:rPr>
+              <a:t>•  **주 지표** — `SRL_ACTIVE`=1, `MRP0` 존재, 두 `SEQUENCE#` 일치, `STATUS`=VALID</a:t>
+            </a:r>
+          </a:p>
+          <a:p>
+            <a:pPr algn="l">
+              <a:spcAft>
+                <a:spcPts val="1000"/>
+              </a:spcAft>
+            </a:pPr>
+            <a:r>
+              <a:rPr sz="1700" b="0">
+                <a:solidFill>
+                  <a:srgbClr val="222222"/>
+                </a:solidFill>
+                <a:latin typeface="맑은 고딕"/>
+              </a:rPr>
+              <a:t>•  **보조 지표** — `transport lag`, `apply lag`</a:t>
+            </a:r>
+          </a:p>
+          <a:p>
+            <a:pPr algn="l">
+              <a:spcAft>
+                <a:spcPts val="1000"/>
+              </a:spcAft>
+            </a:pPr>
+            <a:r>
+              <a:rPr sz="1700" b="0">
+                <a:solidFill>
+                  <a:srgbClr val="222222"/>
+                </a:solidFill>
+                <a:latin typeface="맑은 고딕"/>
+              </a:rPr>
+              <a:t>•  지연은 **두 번 모두 0** 이었다 (14장 속성, 15장 리스너)</a:t>
+            </a:r>
+          </a:p>
+          <a:p>
+            <a:pPr algn="l">
+              <a:spcAft>
+                <a:spcPts val="1000"/>
+              </a:spcAft>
+            </a:pPr>
+            <a:r>
+              <a:rPr sz="1700" b="0">
+                <a:solidFill>
+                  <a:srgbClr val="222222"/>
+                </a:solidFill>
+                <a:latin typeface="맑은 고딕"/>
+              </a:rPr>
+              <a:t>•  주 지표가 무너지면 **끊긴** 것, 보조만 나쁘면 **느린** 것</a:t>
+            </a:r>
+          </a:p>
+        </p:txBody>
+      </p:sp>
+    </p:spTree>
+  </p:cSld>
+  <p:clrMapOvr>
+    <a:masterClrMapping/>
+  </p:clrMapOvr>
+</p:sld>
+</file>
+
+<file path=ppt/slides/slide42.xml><?xml version="1.0" encoding="utf-8"?>
+<p:sld xmlns:a="http://schemas.openxmlformats.org/drawingml/2006/main" xmlns:p="http://schemas.openxmlformats.org/presentationml/2006/main" xmlns:r="http://schemas.openxmlformats.org/officeDocument/2006/relationships">
+  <p:cSld>
+    <p:spTree>
+      <p:nvGrpSpPr>
+        <p:cNvPr id="1" name=""/>
+        <p:cNvGrpSpPr/>
+        <p:nvPr/>
+      </p:nvGrpSpPr>
+      <p:grpSpPr/>
+      <p:sp>
+        <p:nvSpPr>
+          <p:cNvPr id="2" name="Rectangle 1"/>
+          <p:cNvSpPr/>
+          <p:nvPr/>
+        </p:nvSpPr>
+        <p:spPr>
+          <a:xfrm>
+            <a:off x="0" y="0"/>
+            <a:ext cx="12191695" cy="1005840"/>
+          </a:xfrm>
+          <a:prstGeom prst="rect">
+            <a:avLst/>
+          </a:prstGeom>
+          <a:solidFill>
+            <a:srgbClr val="C0392B"/>
+          </a:solidFill>
+          <a:ln>
+            <a:noFill/>
+          </a:ln>
+          <a:effectLst/>
+        </p:spPr>
+        <p:style>
+          <a:lnRef idx="1">
+            <a:schemeClr val="accent1"/>
+          </a:lnRef>
+          <a:fillRef idx="3">
+            <a:schemeClr val="accent1"/>
+          </a:fillRef>
+          <a:effectRef idx="2">
+            <a:schemeClr val="accent1"/>
+          </a:effectRef>
+          <a:fontRef idx="minor">
+            <a:schemeClr val="lt1"/>
+          </a:fontRef>
+        </p:style>
+        <p:txBody>
+          <a:bodyPr rtlCol="0" anchor="ctr"/>
+          <a:lstStyle/>
+          <a:p>
+            <a:pPr algn="ctr"/>
+          </a:p>
+        </p:txBody>
+      </p:sp>
+      <p:sp>
+        <p:nvSpPr>
+          <p:cNvPr id="3" name="TextBox 2"/>
+          <p:cNvSpPr txBox="1"/>
+          <p:nvPr/>
+        </p:nvSpPr>
+        <p:spPr>
+          <a:xfrm>
+            <a:off x="548640" y="91440"/>
+            <a:ext cx="10972800" cy="777240"/>
+          </a:xfrm>
+          <a:prstGeom prst="rect">
+            <a:avLst/>
+          </a:prstGeom>
+          <a:noFill/>
+        </p:spPr>
+        <p:txBody>
+          <a:bodyPr wrap="square">
+            <a:spAutoFit/>
+          </a:bodyPr>
+          <a:lstStyle/>
+          <a:p>
+            <a:pPr algn="l">
+              <a:spcAft>
+                <a:spcPts val="600"/>
+              </a:spcAft>
+            </a:pPr>
+            <a:r>
+              <a:rPr sz="2600" b="1">
+                <a:solidFill>
+                  <a:srgbClr val="FFFFFF"/>
+                </a:solidFill>
+                <a:latin typeface="맑은 고딕"/>
+              </a:rPr>
+              <a:t>판정 규칙</a:t>
+            </a:r>
+          </a:p>
+        </p:txBody>
+      </p:sp>
+      <p:sp>
+        <p:nvSpPr>
+          <p:cNvPr id="4" name="TextBox 3"/>
+          <p:cNvSpPr txBox="1"/>
+          <p:nvPr/>
+        </p:nvSpPr>
+        <p:spPr>
+          <a:xfrm>
+            <a:off x="640080" y="1078992"/>
+            <a:ext cx="10881360" cy="457200"/>
+          </a:xfrm>
+          <a:prstGeom prst="rect">
+            <a:avLst/>
+          </a:prstGeom>
+          <a:noFill/>
+        </p:spPr>
+        <p:txBody>
+          <a:bodyPr wrap="square">
+            <a:spAutoFit/>
+          </a:bodyPr>
+          <a:lstStyle/>
+          <a:p>
+            <a:pPr algn="l">
+              <a:spcAft>
+                <a:spcPts val="600"/>
+              </a:spcAft>
+            </a:pPr>
+            <a:r>
+              <a:rPr sz="1500" b="0">
+                <a:solidFill>
+                  <a:srgbClr val="5A6672"/>
+                </a:solidFill>
+                <a:latin typeface="맑은 고딕"/>
+              </a:rPr>
+              <a:t>네 단계</a:t>
+            </a:r>
+          </a:p>
+        </p:txBody>
+      </p:sp>
+      <p:sp>
+        <p:nvSpPr>
+          <p:cNvPr id="5" name="TextBox 4"/>
+          <p:cNvSpPr txBox="1"/>
+          <p:nvPr/>
+        </p:nvSpPr>
+        <p:spPr>
+          <a:xfrm>
+            <a:off x="640080" y="1737360"/>
+            <a:ext cx="10881360" cy="4754880"/>
+          </a:xfrm>
+          <a:prstGeom prst="rect">
+            <a:avLst/>
+          </a:prstGeom>
+          <a:noFill/>
+        </p:spPr>
+        <p:txBody>
+          <a:bodyPr wrap="square">
+            <a:spAutoFit/>
+          </a:bodyPr>
+          <a:lstStyle/>
+          <a:p>
+            <a:pPr algn="l">
+              <a:spcAft>
+                <a:spcPts val="1000"/>
+              </a:spcAft>
+            </a:pPr>
+            <a:r>
+              <a:rPr sz="1700" b="0">
+                <a:solidFill>
+                  <a:srgbClr val="222222"/>
+                </a:solidFill>
+                <a:latin typeface="맑은 고딕"/>
+              </a:rPr>
+              <a:t>•  **정상** — 모든 기댓값과 일치</a:t>
+            </a:r>
+          </a:p>
+          <a:p>
+            <a:pPr algn="l">
+              <a:spcAft>
+                <a:spcPts val="1000"/>
+              </a:spcAft>
+            </a:pPr>
+            <a:r>
+              <a:rPr sz="1700" b="0">
+                <a:solidFill>
+                  <a:srgbClr val="222222"/>
+                </a:solidFill>
+                <a:latin typeface="맑은 고딕"/>
+              </a:rPr>
+              <a:t>•  **주의** — 지연이 임계값 초과 (`SRL_ACTIVE=1` 인 상태)</a:t>
+            </a:r>
+          </a:p>
+          <a:p>
+            <a:pPr algn="l">
+              <a:spcAft>
+                <a:spcPts val="1000"/>
+              </a:spcAft>
+            </a:pPr>
+            <a:r>
+              <a:rPr sz="1700" b="0">
+                <a:solidFill>
+                  <a:srgbClr val="222222"/>
+                </a:solidFill>
+                <a:latin typeface="맑은 고딕"/>
+              </a:rPr>
+              <a:t>•  **경고** — `DG_ERR&gt;0` 또는 `SEQUENCE#` 차이 2 이상</a:t>
+            </a:r>
+          </a:p>
+          <a:p>
+            <a:pPr algn="l">
+              <a:spcAft>
+                <a:spcPts val="1000"/>
+              </a:spcAft>
+            </a:pPr>
+            <a:r>
+              <a:rPr sz="1700" b="0">
+                <a:solidFill>
+                  <a:srgbClr val="222222"/>
+                </a:solidFill>
+                <a:latin typeface="맑은 고딕"/>
+              </a:rPr>
+              <a:t>•  **심각** — `SRL_ACTIVE=0` / `MRP0` 없음 / `STATUS='ERROR'`</a:t>
+            </a:r>
+          </a:p>
+        </p:txBody>
+      </p:sp>
+    </p:spTree>
+  </p:cSld>
+  <p:clrMapOvr>
+    <a:masterClrMapping/>
+  </p:clrMapOvr>
+</p:sld>
+</file>
+
+<file path=ppt/slides/slide43.xml><?xml version="1.0" encoding="utf-8"?>
+<p:sld xmlns:a="http://schemas.openxmlformats.org/drawingml/2006/main" xmlns:p="http://schemas.openxmlformats.org/presentationml/2006/main" xmlns:r="http://schemas.openxmlformats.org/officeDocument/2006/relationships">
+  <p:cSld>
+    <p:spTree>
+      <p:nvGrpSpPr>
+        <p:cNvPr id="1" name=""/>
+        <p:cNvGrpSpPr/>
+        <p:nvPr/>
+      </p:nvGrpSpPr>
+      <p:grpSpPr/>
+      <p:sp>
+        <p:nvSpPr>
+          <p:cNvPr id="2" name="Rectangle 1"/>
+          <p:cNvSpPr/>
+          <p:nvPr/>
+        </p:nvSpPr>
+        <p:spPr>
+          <a:xfrm>
+            <a:off x="0" y="0"/>
+            <a:ext cx="12191695" cy="1005840"/>
+          </a:xfrm>
+          <a:prstGeom prst="rect">
+            <a:avLst/>
+          </a:prstGeom>
+          <a:solidFill>
+            <a:srgbClr val="C0392B"/>
+          </a:solidFill>
+          <a:ln>
+            <a:noFill/>
+          </a:ln>
+          <a:effectLst/>
+        </p:spPr>
+        <p:style>
+          <a:lnRef idx="1">
+            <a:schemeClr val="accent1"/>
+          </a:lnRef>
+          <a:fillRef idx="3">
+            <a:schemeClr val="accent1"/>
+          </a:fillRef>
+          <a:effectRef idx="2">
+            <a:schemeClr val="accent1"/>
+          </a:effectRef>
+          <a:fontRef idx="minor">
+            <a:schemeClr val="lt1"/>
+          </a:fontRef>
+        </p:style>
+        <p:txBody>
+          <a:bodyPr rtlCol="0" anchor="ctr"/>
+          <a:lstStyle/>
+          <a:p>
+            <a:pPr algn="ctr"/>
+          </a:p>
+        </p:txBody>
+      </p:sp>
+      <p:sp>
+        <p:nvSpPr>
+          <p:cNvPr id="3" name="TextBox 2"/>
+          <p:cNvSpPr txBox="1"/>
+          <p:nvPr/>
+        </p:nvSpPr>
+        <p:spPr>
+          <a:xfrm>
+            <a:off x="548640" y="91440"/>
+            <a:ext cx="10972800" cy="777240"/>
+          </a:xfrm>
+          <a:prstGeom prst="rect">
+            <a:avLst/>
+          </a:prstGeom>
+          <a:noFill/>
+        </p:spPr>
+        <p:txBody>
+          <a:bodyPr wrap="square">
+            <a:spAutoFit/>
+          </a:bodyPr>
+          <a:lstStyle/>
+          <a:p>
+            <a:pPr algn="l">
+              <a:spcAft>
+                <a:spcPts val="600"/>
+              </a:spcAft>
+            </a:pPr>
+            <a:r>
+              <a:rPr sz="2600" b="1">
+                <a:solidFill>
+                  <a:srgbClr val="FFFFFF"/>
+                </a:solidFill>
+                <a:latin typeface="맑은 고딕"/>
+              </a:rPr>
+              <a:t>요약</a:t>
+            </a:r>
+          </a:p>
+        </p:txBody>
+      </p:sp>
+      <p:sp>
+        <p:nvSpPr>
+          <p:cNvPr id="4" name="TextBox 3"/>
+          <p:cNvSpPr txBox="1"/>
+          <p:nvPr/>
+        </p:nvSpPr>
+        <p:spPr>
+          <a:xfrm>
+            <a:off x="640080" y="1371600"/>
+            <a:ext cx="10881360" cy="5120640"/>
+          </a:xfrm>
+          <a:prstGeom prst="rect">
+            <a:avLst/>
+          </a:prstGeom>
+          <a:noFill/>
+        </p:spPr>
+        <p:txBody>
+          <a:bodyPr wrap="square">
+            <a:spAutoFit/>
+          </a:bodyPr>
+          <a:lstStyle/>
+          <a:p>
+            <a:pPr algn="l">
+              <a:spcAft>
+                <a:spcPts val="1000"/>
+              </a:spcAft>
+            </a:pPr>
+            <a:r>
+              <a:rPr sz="1600" b="0">
+                <a:solidFill>
+                  <a:srgbClr val="222222"/>
+                </a:solidFill>
+                <a:latin typeface="맑은 고딕"/>
+              </a:rPr>
+              <a:t>•  Standby 의 온라인 리두는 `SEQUENCE#`가 0, Primary 의 SRL 은 전부 `UNASSIGNED`</a:t>
+            </a:r>
+          </a:p>
+          <a:p>
+            <a:pPr algn="l">
+              <a:spcAft>
+                <a:spcPts val="1000"/>
+              </a:spcAft>
+            </a:pPr>
+            <a:r>
+              <a:rPr sz="1600" b="0">
+                <a:solidFill>
+                  <a:srgbClr val="222222"/>
+                </a:solidFill>
+                <a:latin typeface="맑은 고딕"/>
+              </a:rPr>
+              <a:t>•  SRL 은 **`ACTIVE` 가 정확히 하나**이고 시퀀스가 Primary 와 같아야 한다</a:t>
+            </a:r>
+          </a:p>
+          <a:p>
+            <a:pPr algn="l">
+              <a:spcAft>
+                <a:spcPts val="1000"/>
+              </a:spcAft>
+            </a:pPr>
+            <a:r>
+              <a:rPr sz="1600" b="0">
+                <a:solidFill>
+                  <a:srgbClr val="222222"/>
+                </a:solidFill>
+                <a:latin typeface="맑은 고딕"/>
+              </a:rPr>
+              <a:t>•  `V$ARCHIVE_DEST` 는 설정, `_STATUS` 는 지금 상태</a:t>
+            </a:r>
+          </a:p>
+          <a:p>
+            <a:pPr algn="l">
+              <a:spcAft>
+                <a:spcPts val="1000"/>
+              </a:spcAft>
+            </a:pPr>
+            <a:r>
+              <a:rPr sz="1600" b="0">
+                <a:solidFill>
+                  <a:srgbClr val="222222"/>
+                </a:solidFill>
+                <a:latin typeface="맑은 고딕"/>
+              </a:rPr>
+              <a:t>•  `V$ARCHIVED_LOG` 의 `APPLIED` 는 **`dest_id=2`만** 의미가 있다</a:t>
+            </a:r>
+          </a:p>
+          <a:p>
+            <a:pPr algn="l">
+              <a:spcAft>
+                <a:spcPts val="1000"/>
+              </a:spcAft>
+            </a:pPr>
+            <a:r>
+              <a:rPr sz="1600" b="0">
+                <a:solidFill>
+                  <a:srgbClr val="222222"/>
+                </a:solidFill>
+                <a:latin typeface="맑은 고딕"/>
+              </a:rPr>
+              <a:t>•  `APPLIED_SEQ#`=0 은 정상 — 실시간 적용은 SRL 에서 읽는다</a:t>
+            </a:r>
+          </a:p>
+          <a:p>
+            <a:pPr algn="l">
+              <a:spcAft>
+                <a:spcPts val="1000"/>
+              </a:spcAft>
+            </a:pPr>
+            <a:r>
+              <a:rPr sz="1600" b="0">
+                <a:solidFill>
+                  <a:srgbClr val="222222"/>
+                </a:solidFill>
+                <a:latin typeface="맑은 고딕"/>
+              </a:rPr>
+              <a:t>•  리스너를 내리면 `ERROR` / `INACTIVE` / **`ORA-12541`**</a:t>
+            </a:r>
+          </a:p>
+          <a:p>
+            <a:pPr algn="l">
+              <a:spcAft>
+                <a:spcPts val="1000"/>
+              </a:spcAft>
+            </a:pPr>
+            <a:r>
+              <a:rPr sz="1600" b="0">
+                <a:solidFill>
+                  <a:srgbClr val="222222"/>
+                </a:solidFill>
+                <a:latin typeface="맑은 고딕"/>
+              </a:rPr>
+              <a:t>•  그때도 **두 지연은 0** — 세 번째로 확인</a:t>
+            </a:r>
+          </a:p>
+          <a:p>
+            <a:pPr algn="l">
+              <a:spcAft>
+                <a:spcPts val="1000"/>
+              </a:spcAft>
+            </a:pPr>
+            <a:r>
+              <a:rPr sz="1600" b="0">
+                <a:solidFill>
+                  <a:srgbClr val="222222"/>
+                </a:solidFill>
+                <a:latin typeface="맑은 고딕"/>
+              </a:rPr>
+              <a:t>•  `ENABLE`+`ERROR`=장애, `RESET`=Broker, `DEFER`=사람</a:t>
+            </a:r>
+          </a:p>
+          <a:p>
+            <a:pPr algn="l">
+              <a:spcAft>
+                <a:spcPts val="1000"/>
+              </a:spcAft>
+            </a:pPr>
+            <a:r>
+              <a:rPr sz="1600" b="0">
+                <a:solidFill>
+                  <a:srgbClr val="222222"/>
+                </a:solidFill>
+                <a:latin typeface="맑은 고딕"/>
+              </a:rPr>
+              <a:t>•  판정 기준은 `SEVERITY` 가 아니라 **`ERROR_CODE`**</a:t>
+            </a:r>
+          </a:p>
+          <a:p>
+            <a:pPr algn="l">
+              <a:spcAft>
+                <a:spcPts val="1000"/>
+              </a:spcAft>
+            </a:pPr>
+            <a:r>
+              <a:rPr sz="1600" b="0">
+                <a:solidFill>
+                  <a:srgbClr val="222222"/>
+                </a:solidFill>
+                <a:latin typeface="맑은 고딕"/>
+              </a:rPr>
+              <a:t>•  복구까지 **약 4~5분** (`ReopenSecs` 300)</a:t>
+            </a:r>
+          </a:p>
+          <a:p>
+            <a:pPr algn="l">
+              <a:spcAft>
+                <a:spcPts val="1000"/>
+              </a:spcAft>
+            </a:pPr>
+            <a:r>
+              <a:rPr sz="1600" b="0">
+                <a:solidFill>
+                  <a:srgbClr val="222222"/>
+                </a:solidFill>
+                <a:latin typeface="맑은 고딕"/>
+              </a:rPr>
+              <a:t>•  조치 직후 Broker 가 `ERROR` 인 것은 **판정 시차**</a:t>
+            </a:r>
+          </a:p>
+          <a:p>
+            <a:pPr algn="l">
+              <a:spcAft>
+                <a:spcPts val="1000"/>
+              </a:spcAft>
+            </a:pPr>
+            <a:r>
+              <a:rPr sz="1600" b="0">
+                <a:solidFill>
+                  <a:srgbClr val="222222"/>
+                </a:solidFill>
+                <a:latin typeface="맑은 고딕"/>
+              </a:rPr>
+              <a:t>•  `LOG_ARCHIVE_TRACE` 는 비트마스크, 잘못된 값은 **ORA-02017**</a:t>
+            </a:r>
+          </a:p>
+          <a:p>
+            <a:pPr algn="l">
+              <a:spcAft>
+                <a:spcPts val="1000"/>
+              </a:spcAft>
+            </a:pPr>
+            <a:r>
+              <a:rPr sz="1600" b="0">
+                <a:solidFill>
+                  <a:srgbClr val="222222"/>
+                </a:solidFill>
+                <a:latin typeface="맑은 고딕"/>
+              </a:rPr>
+              <a:t>•  점검표의 핵심은 **`SRL_ACTIVE`**, 지연은 보조 지표</a:t>
+            </a:r>
+          </a:p>
+          <a:p>
+            <a:pPr algn="l">
+              <a:spcAft>
+                <a:spcPts val="1000"/>
+              </a:spcAft>
+            </a:pPr>
+            <a:r>
+              <a:rPr sz="1600" b="0">
+                <a:solidFill>
+                  <a:srgbClr val="222222"/>
+                </a:solidFill>
+                <a:latin typeface="맑은 고딕"/>
+              </a:rPr>
+              <a:t>•  Logical 이면 `MRP0` 도 `V$DATAGUARD_STATS` 도 없다</a:t>
+            </a:r>
+          </a:p>
+          <a:p>
+            <a:pPr algn="l">
+              <a:spcAft>
+                <a:spcPts val="1000"/>
+              </a:spcAft>
+            </a:pPr>
+            <a:r>
+              <a:rPr sz="1600" b="0">
+                <a:solidFill>
+                  <a:srgbClr val="222222"/>
+                </a:solidFill>
+                <a:latin typeface="맑은 고딕"/>
+              </a:rPr>
+              <a:t>•  `V$LOGSTDBY_TRANSACTION` 은 전부 **`PRIMARY_`** 접두어</a:t>
+            </a:r>
+          </a:p>
+        </p:txBody>
+      </p:sp>
+    </p:spTree>
+  </p:cSld>
+  <p:clrMapOvr>
+    <a:masterClrMapping/>
+  </p:clrMapOvr>
+</p:sld>
+</file>
+
+<file path=ppt/slides/slide44.xml><?xml version="1.0" encoding="utf-8"?>
 <p:sld xmlns:a="http://schemas.openxmlformats.org/drawingml/2006/main" xmlns:p="http://schemas.openxmlformats.org/presentationml/2006/main" xmlns:r="http://schemas.openxmlformats.org/officeDocument/2006/relationships">
   <p:cSld>
     <p:spTree>

</xml_diff>